<commit_message>
Add final deliverables: presentation, citations, demo script
- MaxGPT_Presentation.pptx: 13-slide deck covering all 7 rubric elements,
  speaker notes on every slide.
- CITATIONS.md: full citations (7 datasets, papers, libraries, honest AI-use).
- DEMO_SCRIPT.md: shot-list + narration for the demo video.
- .gitignore: exclude .deck_build/ and webui-venv/.
</commit_message>
<xml_diff>
--- a/MaxGPT_Presentation.pptx
+++ b/MaxGPT_Presentation.pptx
@@ -752,7 +752,7 @@
           <a:p>
             <a:r>
               <a:rPr lang="en-US" dirty="0"/>
-              <a:t>Hook: I trained four conversational language models entirely from scratch in PyTorch — no pretrained weights, no Hugging Face transformers library. I wrote the tokenizer, the transformer, and the training loop myself. This is the story of what happens when you scale a tiny model 10x, and then fine-tune it into a chatbot. Start confident, set the scope: four models, 23 million up to 235 million parameters.</a:t>
+              <a:t>Hook: I trained four conversational language models entirely from scratch in PyTorch, no pretrained weights, no Hugging Face transformers library. I wrote the tokenizer, the transformer, and the training loop myself. This is the story of what happens when you scale a tiny model 10x, and then fine-tune it into a chatbot. Start confident, set the scope: four models, 23 million up to 235 million parameters.</a:t>
             </a:r>
             <a:endParaRPr lang="en-US" dirty="0"/>
           </a:p>
@@ -840,7 +840,7 @@
           <a:p>
             <a:r>
               <a:rPr lang="en-US" dirty="0"/>
-              <a:t>Real engineering means real debugging. Four challenges. One: my GPU's PyTorch build shipped without Flash Attention — I diagnosed it, forced a different attention backend, then switched to Linux through WSL2 to get the fast version. Two: a sneaky bug where one whole dataset ended up in validation, so the model trained on only stories and spat gibberish at chat prompts — fixed by splitting each dataset separately. Three: during fine-tuning, my loss mask matched zero tokens because byte-pair encoding had eaten my role markers — fixed by matching at the byte level. Four: I kept hitting the 12 GB memory ceiling — fixed by loading checkpoints to CPU first. Be ready to go deeper on any of these if asked.</a:t>
+              <a:t>Real engineering means real debugging. Four challenges. One: my GPU's PyTorch build shipped without Flash Attention, I diagnosed it, forced a different attention backend, then switched to Linux through WSL2 to get the fast version. Two: a sneaky bug where one whole dataset ended up in validation, so the model trained on only stories and spat gibberish at chat prompts, fixed by splitting each dataset separately. Three: during fine-tuning, my loss mask matched zero tokens because byte-pair encoding had eaten my role markers, fixed by matching at the byte level. Four: I kept hitting the 12 GB memory ceiling, fixed by loading checkpoints to CPU first. Be ready to go deeper on any of these if asked.</a:t>
             </a:r>
             <a:endParaRPr lang="en-US" dirty="0"/>
           </a:p>
@@ -928,7 +928,7 @@
           <a:p>
             <a:r>
               <a:rPr lang="en-US" dirty="0"/>
-              <a:t>If I made a version 2: a bigger vocabulary so each token means more; modern architecture pieces — RMSNorm, SwiGLU, RoPE — which I deliberately skipped to keep a clean scale-only comparison; cleaner fine-tuning data plus replaying pre-train text so it doesn't lose its general skills; resume-from-checkpoint so a crash doesn't cost days; a proper evaluation harness with perplexity and benchmark scores; and quantization so it could run on a phone. Each of these I can explain why it would help.</a:t>
+              <a:t>If I made a version 2: a bigger vocabulary so each token means more; modern architecture pieces, RMSNorm, SwiGLU, RoPE, which I deliberately skipped to keep a clean scale-only comparison; cleaner fine-tuning data plus replaying pre-train text so it doesn't lose its general skills; resume-from-checkpoint so a crash doesn't cost days; a proper evaluation harness with perplexity and benchmark scores; and quantization so it could run on a phone. Each of these I can explain why it would help.</a:t>
             </a:r>
             <a:endParaRPr lang="en-US" dirty="0"/>
           </a:p>
@@ -1016,7 +1016,7 @@
           <a:p>
             <a:r>
               <a:rPr lang="en-US" dirty="0"/>
-              <a:t>Citations — the honesty slide. The architecture comes from the Transformer and BPE papers; the whole 'small model on focused data' idea from TinyStories; the scaling recipe from Chinchilla and LLaMA. My main tutorial was Andrej Karpathy's 'Let's build GPT' videos. Seven datasets, all credited. Libraries: PyTorch, Hugging Face datasets, NumPy, tqdm, Streamlit. And critically — I used Claude as an AI assistant for architecture discussions, pseudo-code, code review, debugging, and help with this evaluation and presentation. But I wrote and understand every line of code myself. The rule was: cite it, modify it, understand it — and I did all three.</a:t>
+              <a:t>Citations, the honesty slide. The architecture comes from the Transformer and BPE papers; the whole 'small model on focused data' idea from TinyStories; the scaling recipe from Chinchilla and LLaMA. My main tutorial was Andrej Karpathy's 'Let's build GPT' videos. Seven datasets, all credited. Libraries: PyTorch, Hugging Face datasets, NumPy, tqdm, Streamlit. And critically, I used Claude as an AI assistant for architecture discussions, pseudo-code, code review, debugging, and help with this evaluation and presentation. But I wrote and understand every line of code myself. The rule was: cite it, modify it, understand it, and I did all three.</a:t>
             </a:r>
             <a:endParaRPr lang="en-US" dirty="0"/>
           </a:p>
@@ -1104,7 +1104,7 @@
           <a:p>
             <a:r>
               <a:rPr lang="en-US" dirty="0"/>
-              <a:t>Close on the demo. I'll show the web app live — chatting and the side-by-side compare. The one-line summary of the whole project: I didn't fine-tune someone else's model — I built the tokenizer, the transformer, and the training loop, and watched coherence emerge as I scaled the model 10x. Four models, about 28 exaFLOPs of training on a single gaming GPU — roughly ten-thousand times less compute than GPT-3, but demonstrating every concept that makes GPT-4 work. Thank you — happy to take questions.</a:t>
+              <a:t>Close on the demo. I'll show the web app live, chatting and the side-by-side compare. The one-line summary of the whole project: I didn't fine-tune someone else's model, I built the tokenizer, the transformer, and the training loop, and watched coherence emerge as I scaled the model 10x. Four models, about 28 exaFLOPs of training on a single gaming GPU, roughly ten-thousand times less compute than GPT-3, but demonstrating every concept that makes GPT-4 work. Thank you, happy to take questions.</a:t>
             </a:r>
             <a:endParaRPr lang="en-US" dirty="0"/>
           </a:p>
@@ -1192,7 +1192,7 @@
           <a:p>
             <a:r>
               <a:rPr lang="en-US" dirty="0"/>
-              <a:t>The problem I set out to solve was my own understanding. Everyone uses these models, almost nobody has built one. My three goals: (1) understand by building every piece from scratch; (2) demonstrate scaling — same architecture, grown 10x; (3) produce a real chatbot plus a web app. Emphasize: this is a learning-and-demonstration project, and the 'product' is both the models and the understanding.</a:t>
+              <a:t>The problem I set out to solve was my own understanding. Everyone uses these models, almost nobody has built one. My three goals: (1) understand by building every piece from scratch; (2) demonstrate scaling, same architecture, grown 10x; (3) produce a real chatbot plus a web app. Emphasize: this is a learning-and-demonstration project, and the 'product' is both the models and the understanding.</a:t>
             </a:r>
             <a:endParaRPr lang="en-US" dirty="0"/>
           </a:p>
@@ -1280,7 +1280,7 @@
           <a:p>
             <a:r>
               <a:rPr lang="en-US" dirty="0"/>
-              <a:t>Two questions. Why is AI the right tool? Because language generation can't be done with hand-written rules — it needs a model that learns patterns from data. That's the definition of a deep-learning problem. Why from scratch instead of the OpenAI API? Because the API hides everything; building it myself is what proves I understand it. And small models are genuinely useful — they run on a laptop or phone, cheaply and privately.</a:t>
+              <a:t>Two questions. Why is AI the right tool? Because language generation can't be done with hand-written rules, it needs a model that learns patterns from data. That's the definition of a deep-learning problem. Why from scratch instead of the OpenAI API? Because the API hides everything; building it myself is what proves I understand it. And small models are genuinely useful, they run on a laptop or phone, cheaply and privately.</a:t>
             </a:r>
             <a:endParaRPr lang="en-US" dirty="0"/>
           </a:p>
@@ -1368,7 +1368,7 @@
           <a:p>
             <a:r>
               <a:rPr lang="en-US" dirty="0"/>
-              <a:t>This is the core of the project. Same transformer architecture, scaled three times: 23 million, 110 million, 235 million parameters — about 10x from first to last. MaxGPT-1 just gets coherent English. MaxGPT-2 learns the chat format. MaxGPT-3 is trained on a seven-dataset, five-billion-token mix for almost a week and becomes a real chatbot. MaxGPT-3.5 is MaxGPT-3 fine-tuned on chat-only data. Total compute ~28 exaFLOPs — sounds huge, but GPT-3 used about 10,000 times more. Mine ran on one gaming GPU.</a:t>
+              <a:t>This is the core of the project. Same transformer architecture, scaled three times: 23 million, 110 million, 235 million parameters, about 10x from first to last. MaxGPT-1 just gets coherent English. MaxGPT-2 learns the chat format. MaxGPT-3 is trained on a seven-dataset, five-billion-token mix for almost a week and becomes a real chatbot. MaxGPT-3.5 is MaxGPT-3 fine-tuned on chat-only data. Total compute ~28 exaFLOPs, sounds huge, but GPT-3 used about 10,000 times more. Mine ran on one gaming GPU.</a:t>
             </a:r>
             <a:endParaRPr lang="en-US" dirty="0"/>
           </a:p>
@@ -1456,7 +1456,7 @@
           <a:p>
             <a:r>
               <a:rPr lang="en-US" dirty="0"/>
-              <a:t>Feature one: the tokenizer. It breaks text into sub-word tokens using byte-pair encoding, trained from scratch with a 16,000-token vocabulary. My naive first version took over 20 hours just for data prep, because it rescanned the whole token list on every merge. I rebuilt it with a doubly-linked list — so merging two tokens is O(1) — and a min-heap to always grab the next merge in O(log n). Result: 31x faster training and 465x faster encoding — from 1100 seconds per chunk down to about 2 seconds. Without this, MaxGPT-3's data prep would've taken weeks instead of hours.</a:t>
+              <a:t>Feature one: the tokenizer. It breaks text into sub-word tokens using byte-pair encoding, trained from scratch with a 16,000-token vocabulary. My naive first version took over 20 hours just for data prep, because it rescanned the whole token list on every merge. I rebuilt it with a doubly-linked list, so merging two tokens is O(1), and a min-heap to always grab the next merge in O(log n). Result: 31x faster training and 465x faster encoding, from 1100 seconds per chunk down to about 2 seconds. Without this, MaxGPT-3's data prep would've taken weeks instead of hours.</a:t>
             </a:r>
             <a:endParaRPr lang="en-US" dirty="0"/>
           </a:p>
@@ -1544,7 +1544,7 @@
           <a:p>
             <a:r>
               <a:rPr lang="en-US" dirty="0"/>
-              <a:t>Feature two: the transformer itself, written by hand. This is the attention mechanism — the heart of the model. I project the input into query, key, and value vectors, compute how much each token should attend to every earlier token, apply a causal mask so it can't peek at future tokens, softmax into weights, and take a weighted sum. On the right are all the pieces I built: multi-head attention, the feed-forward network with GELU, pre-norm and residual connections, learned positional embeddings, sixteen blocks stacked. I can toggle a flag to run this exact manual math, or the optimized Flash-attention path. I understand every line.</a:t>
+              <a:t>Feature two: the transformer itself, written by hand. This is the attention mechanism, the heart of the model. I project the input into query, key, and value vectors, compute how much each token should attend to every earlier token, apply a causal mask so it can't peek at future tokens, softmax into weights, and take a weighted sum. On the right are all the pieces I built: multi-head attention, the feed-forward network with GELU, pre-norm and residual connections, learned positional embeddings, sixteen blocks stacked. I can toggle a flag to run this exact manual math, or the optimized Flash-attention path. I understand every line.</a:t>
             </a:r>
             <a:endParaRPr lang="en-US" dirty="0"/>
           </a:p>
@@ -1632,7 +1632,7 @@
           <a:p>
             <a:r>
               <a:rPr lang="en-US" dirty="0"/>
-              <a:t>Feature three: the web app, built in Streamlit. It has a chat mode with real multi-turn memory, and a compare mode that races models side by side on the same prompt with live token-by-token streaming — that typing effect you see in ChatGPT. A tricky part: all four models share the same class names, so I wrote an import-collision loader that namespaces each one so they can all run in a single app. On the right is a mock of compare mode — and the next slide shows a real four-way comparison.</a:t>
+              <a:t>Feature three: the web app, built in Streamlit. It has a chat mode with real multi-turn memory, and a compare mode that races models side by side on the same prompt with live token-by-token streaming, that typing effect you see in ChatGPT. A tricky part: all four models share the same class names, so I wrote an import-collision loader that namespaces each one so they can all run in a single app. On the right is a mock of compare mode, and the next slide shows a real four-way comparison.</a:t>
             </a:r>
             <a:endParaRPr lang="en-US" dirty="0"/>
           </a:p>
@@ -1720,7 +1720,7 @@
           <a:p>
             <a:r>
               <a:rPr lang="en-US" dirty="0"/>
-              <a:t>This single prompt captures the entire project. MaxGPT-1: total word salad. MaxGPT-2: grammatical and recipe-shaped, but it suggests brownies with tofu and ground pork, and bleeds the training format. MaxGPT-3: a genuinely real-looking recipe — it just wanders off into French étouffée instead of brownies. MaxGPT-3.5, the fine-tuned one: clean assistant formatting, and it actually stays on brownies. None of them get a correct recipe — 235M params is still tiny — but you can SEE both the scaling story and the fine-tuning shift in one screenshot. This is my favorite slide.</a:t>
+              <a:t>This single prompt captures the entire project. MaxGPT-1: total word salad. MaxGPT-2: grammatical and recipe-shaped, but it suggests brownies with tofu and ground pork, and bleeds the training format. MaxGPT-3: a genuinely real-looking recipe, it just wanders off into French étouffée instead of brownies. MaxGPT-3.5, the fine-tuned one: clean assistant formatting, and it actually stays on brownies. None of them get a correct recipe, 235M params is still tiny, but you can SEE both the scaling story and the fine-tuning shift in one screenshot. This is my favorite slide.</a:t>
             </a:r>
             <a:endParaRPr lang="en-US" dirty="0"/>
           </a:p>
@@ -1808,7 +1808,7 @@
           <a:p>
             <a:r>
               <a:rPr lang="en-US" dirty="0"/>
-              <a:t>I went one step past the assignment: a real fine-tuning phase plus a rigorous evaluation. SFT means continuing to train MaxGPT-3 on chat-only data, but masking the loss so it only learns from the assistant's replies. Then — and this is the part I'm proud of — I evaluated it honestly, with blind multi-sample scoring across checkpoints, not just cherry-picked examples. The headline result: on cross-turn reference resolution — resolving 'feed HIM' back to the puppy — the base model succeeded 25% of the time, the fine-tuned one 92%. But it's a trade-off: the fine-tuned model is more verbose. I reported that honestly rather than overselling it.</a:t>
+              <a:t>I went one step past the assignment: a real fine-tuning phase plus a rigorous evaluation. SFT means continuing to train MaxGPT-3 on chat-only data, but masking the loss so it only learns from the assistant's replies. Then, and this is the part I'm proud of, I evaluated it honestly, with blind multi-sample scoring across checkpoints, not just cherry-picked examples. The headline result: on cross-turn reference resolution, resolving 'feed HIM' back to the puppy, the base model succeeded 25% of the time, the fine-tuned one 92%. But it's a trade-off: the fine-tuned model is more verbose. I reported that honestly rather than overselling it.</a:t>
             </a:r>
             <a:endParaRPr lang="en-US" dirty="0"/>
           </a:p>
@@ -3353,7 +3353,7 @@
                 <a:ea typeface="Consolas" pitchFamily="34" charset="-122"/>
                 <a:cs typeface="Consolas" pitchFamily="34" charset="-120"/>
               </a:rPr>
-              <a:t>MaxGPT  ·  Max — CS Final Project</a:t>
+              <a:t>MaxGPT  ·  Max, CS Final Project</a:t>
             </a:r>
             <a:endParaRPr lang="en-US" sz="900" dirty="0"/>
           </a:p>
@@ -3713,7 +3713,7 @@
                 <a:ea typeface="Calibri" pitchFamily="34" charset="-122"/>
                 <a:cs typeface="Calibri" pitchFamily="34" charset="-120"/>
               </a:rPr>
-              <a:t>32K–50K tokens so each token carries more meaning.</a:t>
+              <a:t>32K-50K tokens so each token carries more meaning.</a:t>
             </a:r>
             <a:endParaRPr lang="en-US" sz="1250" dirty="0"/>
           </a:p>
@@ -4163,7 +4163,7 @@
                 <a:ea typeface="Calibri" pitchFamily="34" charset="-122"/>
                 <a:cs typeface="Calibri" pitchFamily="34" charset="-120"/>
               </a:rPr>
-              <a:t>Restart training mid-run after a crash — this bit me once.</a:t>
+              <a:t>Restart training mid-run after a crash, this bit me once.</a:t>
             </a:r>
             <a:endParaRPr lang="en-US" sz="1250" dirty="0"/>
           </a:p>
@@ -4502,7 +4502,7 @@
                 <a:ea typeface="Consolas" pitchFamily="34" charset="-122"/>
                 <a:cs typeface="Consolas" pitchFamily="34" charset="-120"/>
               </a:rPr>
-              <a:t>MaxGPT  ·  Max — CS Final Project</a:t>
+              <a:t>MaxGPT  ·  Max, CS Final Project</a:t>
             </a:r>
             <a:endParaRPr lang="en-US" sz="900" dirty="0"/>
           </a:p>
@@ -4846,7 +4846,7 @@
                 <a:ea typeface="Calibri" pitchFamily="34" charset="-122"/>
                 <a:cs typeface="Calibri" pitchFamily="34" charset="-120"/>
               </a:rPr>
-              <a:t>Vaswani et al. 2017 — Transformers (“Attention Is All You Need”)</a:t>
+              <a:t>Vaswani et al. 2017, Transformers (“Attention Is All You Need”)</a:t>
             </a:r>
             <a:endParaRPr lang="en-US" sz="1150" dirty="0"/>
           </a:p>
@@ -4867,7 +4867,7 @@
                 <a:ea typeface="Calibri" pitchFamily="34" charset="-122"/>
                 <a:cs typeface="Calibri" pitchFamily="34" charset="-120"/>
               </a:rPr>
-              <a:t>Sennrich et al. 2016 — BPE subword tokenization</a:t>
+              <a:t>Sennrich et al. 2016, BPE subword tokenization</a:t>
             </a:r>
             <a:endParaRPr lang="en-US" sz="1150" dirty="0"/>
           </a:p>
@@ -4888,7 +4888,7 @@
                 <a:ea typeface="Calibri" pitchFamily="34" charset="-122"/>
                 <a:cs typeface="Calibri" pitchFamily="34" charset="-120"/>
               </a:rPr>
-              <a:t>Eldan &amp; Li 2023 — TinyStories</a:t>
+              <a:t>Eldan &amp; Li 2023, TinyStories</a:t>
             </a:r>
             <a:endParaRPr lang="en-US" sz="1150" dirty="0"/>
           </a:p>
@@ -4909,7 +4909,7 @@
                 <a:ea typeface="Calibri" pitchFamily="34" charset="-122"/>
                 <a:cs typeface="Calibri" pitchFamily="34" charset="-120"/>
               </a:rPr>
-              <a:t>Hoffmann 2022 — Chinchilla scaling; Touvron 2023 — LLaMA; Dao 2022 — FlashAttention</a:t>
+              <a:t>Hoffmann 2022, Chinchilla scaling; Touvron 2023, LLaMA; Dao 2022, FlashAttention</a:t>
             </a:r>
             <a:endParaRPr lang="en-US" sz="1150" dirty="0"/>
           </a:p>
@@ -5043,7 +5043,7 @@
                 <a:ea typeface="Calibri" pitchFamily="34" charset="-122"/>
                 <a:cs typeface="Calibri" pitchFamily="34" charset="-120"/>
               </a:rPr>
-              <a:t>Andrej Karpathy — “Let's build GPT” &amp; “GPT Tokenizer”, nanoGPT</a:t>
+              <a:t>Andrej Karpathy, “Let's build GPT” &amp; “GPT Tokenizer”, nanoGPT</a:t>
             </a:r>
             <a:endParaRPr lang="en-US" sz="1150" dirty="0"/>
           </a:p>
@@ -5423,7 +5423,7 @@
                 <a:ea typeface="Consolas" pitchFamily="34" charset="-122"/>
                 <a:cs typeface="Consolas" pitchFamily="34" charset="-120"/>
               </a:rPr>
-              <a:t>MaxGPT  ·  Max — CS Final Project</a:t>
+              <a:t>MaxGPT  ·  Max, CS Final Project</a:t>
             </a:r>
             <a:endParaRPr lang="en-US" sz="900" dirty="0"/>
           </a:p>
@@ -5572,7 +5572,7 @@
                 <a:ea typeface="Calibri" pitchFamily="34" charset="-122"/>
                 <a:cs typeface="Calibri" pitchFamily="34" charset="-120"/>
               </a:rPr>
-              <a:t>Live in the browser — chat with any model, or race them in compare mode and watch the quality jump.</a:t>
+              <a:t>Live in the browser, chat with any model, or race them in compare mode and watch the quality jump.</a:t>
             </a:r>
             <a:endParaRPr lang="en-US" sz="1700" dirty="0"/>
           </a:p>
@@ -5663,7 +5663,7 @@
                 <a:ea typeface="Trebuchet MS" pitchFamily="34" charset="-122"/>
                 <a:cs typeface="Trebuchet MS" pitchFamily="34" charset="-120"/>
               </a:rPr>
-              <a:t>“I didn't fine-tune someone else's model. I built the tokenizer, the transformer, and the training loop — and watched coherence emerge as I scaled from 23M to 235M parameters.”</a:t>
+              <a:t>“I didn't fine-tune someone else's model. I built the tokenizer, the transformer, and the training loop, and watched coherence emerge as I scaled from 23M to 235M parameters.”</a:t>
             </a:r>
             <a:endParaRPr lang="en-US" sz="2100" dirty="0"/>
           </a:p>
@@ -5819,7 +5819,7 @@
                 <a:ea typeface="Calibri" pitchFamily="34" charset="-122"/>
                 <a:cs typeface="Calibri" pitchFamily="34" charset="-120"/>
               </a:rPr>
-              <a:t>of training — on one gaming GPU</a:t>
+              <a:t>of training, on one gaming GPU</a:t>
             </a:r>
             <a:endParaRPr lang="en-US" sz="1300" dirty="0"/>
           </a:p>
@@ -5936,7 +5936,7 @@
                 <a:ea typeface="Consolas" pitchFamily="34" charset="-122"/>
                 <a:cs typeface="Consolas" pitchFamily="34" charset="-120"/>
               </a:rPr>
-              <a:t>MaxGPT  ·  Max — CS Final Project</a:t>
+              <a:t>MaxGPT  ·  Max, CS Final Project</a:t>
             </a:r>
             <a:endParaRPr lang="en-US" sz="900" dirty="0"/>
           </a:p>
@@ -6066,7 +6066,7 @@
                 <a:ea typeface="Trebuchet MS" pitchFamily="34" charset="-122"/>
                 <a:cs typeface="Trebuchet MS" pitchFamily="34" charset="-120"/>
               </a:rPr>
-              <a:t>Purpose — open the black box</a:t>
+              <a:t>Purpose: open the black box</a:t>
             </a:r>
             <a:endParaRPr lang="en-US" sz="2800" dirty="0"/>
           </a:p>
@@ -6185,7 +6185,7 @@
                 <a:ea typeface="Calibri" pitchFamily="34" charset="-122"/>
                 <a:cs typeface="Calibri" pitchFamily="34" charset="-120"/>
               </a:rPr>
-              <a:t>Most people use ChatGPT as a black box. I wanted to understand how it actually works — by building every piece myself.</a:t>
+              <a:t>Most people use ChatGPT as a black box. I wanted to understand how it actually works, by building every piece myself.</a:t>
             </a:r>
             <a:endParaRPr lang="en-US" sz="1700" dirty="0"/>
           </a:p>
@@ -6354,7 +6354,7 @@
                 <a:ea typeface="Calibri" pitchFamily="34" charset="-122"/>
                 <a:cs typeface="Calibri" pitchFamily="34" charset="-120"/>
               </a:rPr>
-              <a:t>Write the tokenizer, the transformer, and the training loop by hand — every line, no shortcuts, no API calls.</a:t>
+              <a:t>Write the tokenizer, the transformer, and the training loop by hand, every line, no shortcuts, no API calls.</a:t>
             </a:r>
             <a:endParaRPr lang="en-US" sz="1350" dirty="0"/>
           </a:p>
@@ -6731,7 +6731,7 @@
                 <a:ea typeface="Consolas" pitchFamily="34" charset="-122"/>
                 <a:cs typeface="Consolas" pitchFamily="34" charset="-120"/>
               </a:rPr>
-              <a:t>MaxGPT  ·  Max — CS Final Project</a:t>
+              <a:t>MaxGPT  ·  Max, CS Final Project</a:t>
             </a:r>
             <a:endParaRPr lang="en-US" sz="900" dirty="0"/>
           </a:p>
@@ -6861,7 +6861,7 @@
                 <a:ea typeface="Trebuchet MS" pitchFamily="34" charset="-122"/>
                 <a:cs typeface="Trebuchet MS" pitchFamily="34" charset="-120"/>
               </a:rPr>
-              <a:t>Why AI — and why from scratch?</a:t>
+              <a:t>Why AI, and why from scratch?</a:t>
             </a:r>
             <a:endParaRPr lang="en-US" sz="2800" dirty="0"/>
           </a:p>
@@ -7123,7 +7123,7 @@
                 <a:ea typeface="Calibri" pitchFamily="34" charset="-122"/>
                 <a:cs typeface="Calibri" pitchFamily="34" charset="-120"/>
               </a:rPr>
-              <a:t>Generating coherent text is fundamentally a deep-learning problem — exactly the kind of task AI exists for.</a:t>
+              <a:t>Generating coherent text is fundamentally a deep-learning problem, exactly the kind of task AI exists for.</a:t>
             </a:r>
             <a:endParaRPr lang="en-US" sz="1500" dirty="0"/>
           </a:p>
@@ -7276,7 +7276,7 @@
                 <a:ea typeface="Calibri" pitchFamily="34" charset="-122"/>
                 <a:cs typeface="Calibri" pitchFamily="34" charset="-120"/>
               </a:rPr>
-              <a:t>Building from scratch proves I understand the fundamentals — every architectural decision, every line of code.</a:t>
+              <a:t>Building from scratch proves I understand the fundamentals, every architectural decision, every line of code.</a:t>
             </a:r>
             <a:endParaRPr lang="en-US" sz="1500" dirty="0"/>
           </a:p>
@@ -7344,7 +7344,7 @@
                 <a:ea typeface="Consolas" pitchFamily="34" charset="-122"/>
                 <a:cs typeface="Consolas" pitchFamily="34" charset="-120"/>
               </a:rPr>
-              <a:t>MaxGPT  ·  Max — CS Final Project</a:t>
+              <a:t>MaxGPT  ·  Max, CS Final Project</a:t>
             </a:r>
             <a:endParaRPr lang="en-US" sz="900" dirty="0"/>
           </a:p>
@@ -9110,7 +9110,7 @@
                           <a:ea typeface="Calibri" pitchFamily="34" charset="-122"/>
                           <a:cs typeface="Calibri" pitchFamily="34" charset="-120"/>
                         </a:rPr>
-                        <a:t>~6–7 days</a:t>
+                        <a:t>~6-7 days</a:t>
                       </a:r>
                       <a:endParaRPr lang="en-US" sz="1250" dirty="0">
                         <a:latin typeface="Calibri" charset="0"/>
@@ -9178,7 +9178,7 @@
                           <a:ea typeface="Calibri" pitchFamily="34" charset="-122"/>
                           <a:cs typeface="Calibri" pitchFamily="34" charset="-120"/>
                         </a:rPr>
-                        <a:t>A real chatbot — 7-dataset, ~5B-token mix</a:t>
+                        <a:t>A real chatbot, 7-dataset, ~5B-token mix</a:t>
                       </a:r>
                       <a:endParaRPr lang="en-US" sz="1250" dirty="0">
                         <a:latin typeface="Calibri" charset="0"/>
@@ -9810,7 +9810,7 @@
                 <a:ea typeface="Consolas" pitchFamily="34" charset="-122"/>
                 <a:cs typeface="Consolas" pitchFamily="34" charset="-120"/>
               </a:rPr>
-              <a:t>MaxGPT  ·  Max — CS Final Project</a:t>
+              <a:t>MaxGPT  ·  Max, CS Final Project</a:t>
             </a:r>
             <a:endParaRPr lang="en-US" sz="900" dirty="0"/>
           </a:p>
@@ -9940,7 +9940,7 @@
                 <a:ea typeface="Trebuchet MS" pitchFamily="34" charset="-122"/>
                 <a:cs typeface="Trebuchet MS" pitchFamily="34" charset="-120"/>
               </a:rPr>
-              <a:t>Feature 1 — custom BPE tokenizer</a:t>
+              <a:t>Feature 1: custom BPE tokenizer</a:t>
             </a:r>
             <a:endParaRPr lang="en-US" sz="2800" dirty="0"/>
           </a:p>
@@ -10059,7 +10059,7 @@
                 <a:ea typeface="Calibri" pitchFamily="34" charset="-122"/>
                 <a:cs typeface="Calibri" pitchFamily="34" charset="-120"/>
               </a:rPr>
-              <a:t>Turns text into tokens via byte-pair encoding — trained from scratch, 16,000-word vocabulary. My first version took 20+ hours, so I rebuilt it.</a:t>
+              <a:t>Turns text into tokens via byte-pair encoding, trained from scratch, 16,000-word vocabulary. My first version took 20+ hours, so I rebuilt it.</a:t>
             </a:r>
             <a:endParaRPr lang="en-US" sz="1500" dirty="0"/>
           </a:p>
@@ -10771,7 +10771,7 @@
                 <a:ea typeface="Consolas" pitchFamily="34" charset="-122"/>
                 <a:cs typeface="Consolas" pitchFamily="34" charset="-120"/>
               </a:rPr>
-              <a:t>MaxGPT  ·  Max — CS Final Project</a:t>
+              <a:t>MaxGPT  ·  Max, CS Final Project</a:t>
             </a:r>
             <a:endParaRPr lang="en-US" sz="900" dirty="0"/>
           </a:p>
@@ -10901,7 +10901,7 @@
                 <a:ea typeface="Trebuchet MS" pitchFamily="34" charset="-122"/>
                 <a:cs typeface="Trebuchet MS" pitchFamily="34" charset="-120"/>
               </a:rPr>
-              <a:t>Feature 2 — the transformer, by hand</a:t>
+              <a:t>Feature 2: the transformer, by hand</a:t>
             </a:r>
             <a:endParaRPr lang="en-US" sz="2800" dirty="0"/>
           </a:p>
@@ -11020,7 +11020,7 @@
                 <a:ea typeface="Calibri" pitchFamily="34" charset="-122"/>
                 <a:cs typeface="Calibri" pitchFamily="34" charset="-120"/>
               </a:rPr>
-              <a:t>A decoder-only (GPT-style) transformer written from scratch in PyTorch — no nn.Transformer, no pretrained weights.</a:t>
+              <a:t>A decoder-only (GPT-style) transformer written from scratch in PyTorch, no nn.Transformer, no pretrained weights.</a:t>
             </a:r>
             <a:endParaRPr lang="en-US" sz="1500" dirty="0"/>
           </a:p>
@@ -11535,7 +11535,7 @@
                 <a:ea typeface="Consolas" pitchFamily="34" charset="-122"/>
                 <a:cs typeface="Consolas" pitchFamily="34" charset="-120"/>
               </a:rPr>
-              <a:t>MaxGPT  ·  Max — CS Final Project</a:t>
+              <a:t>MaxGPT  ·  Max, CS Final Project</a:t>
             </a:r>
             <a:endParaRPr lang="en-US" sz="900" dirty="0"/>
           </a:p>
@@ -11665,7 +11665,7 @@
                 <a:ea typeface="Trebuchet MS" pitchFamily="34" charset="-122"/>
                 <a:cs typeface="Trebuchet MS" pitchFamily="34" charset="-120"/>
               </a:rPr>
-              <a:t>Feature 3 — interactive web app</a:t>
+              <a:t>Feature 3: interactive web app</a:t>
             </a:r>
             <a:endParaRPr lang="en-US" sz="2800" dirty="0"/>
           </a:p>
@@ -12504,7 +12504,7 @@
                 <a:ea typeface="Consolas" pitchFamily="34" charset="-122"/>
                 <a:cs typeface="Consolas" pitchFamily="34" charset="-120"/>
               </a:rPr>
-              <a:t>MaxGPT  ·  Max — CS Final Project</a:t>
+              <a:t>MaxGPT  ·  Max, CS Final Project</a:t>
             </a:r>
             <a:endParaRPr lang="en-US" sz="900" dirty="0"/>
           </a:p>
@@ -12753,7 +12753,7 @@
                 <a:ea typeface="Consolas" pitchFamily="34" charset="-122"/>
                 <a:cs typeface="Consolas" pitchFamily="34" charset="-120"/>
               </a:rPr>
-              <a:t>“can you give me a recipe for brownies?”  —  the same prompt through all four models</a:t>
+              <a:t>“can you give me a recipe for brownies?”  ·  the same prompt through all four models</a:t>
             </a:r>
             <a:endParaRPr lang="en-US" sz="1300" dirty="0"/>
           </a:p>
@@ -12942,7 +12942,7 @@
                 <a:ea typeface="Calibri" pitchFamily="34" charset="-122"/>
                 <a:cs typeface="Calibri" pitchFamily="34" charset="-120"/>
               </a:rPr>
-              <a:t>Word salad — can't form a coherent thought.</a:t>
+              <a:t>Word salad, can't form a coherent thought.</a:t>
             </a:r>
             <a:endParaRPr lang="en-US" sz="1200" dirty="0"/>
           </a:p>
@@ -13320,7 +13320,7 @@
                 <a:ea typeface="Calibri" pitchFamily="34" charset="-122"/>
                 <a:cs typeface="Calibri" pitchFamily="34" charset="-120"/>
               </a:rPr>
-              <a:t>A real recipe format — just the wrong dish. Coherent, off-topic.</a:t>
+              <a:t>A real recipe format, just the wrong dish. Coherent, off-topic.</a:t>
             </a:r>
             <a:endParaRPr lang="en-US" sz="1200" dirty="0"/>
           </a:p>
@@ -13548,7 +13548,7 @@
                 <a:ea typeface="Consolas" pitchFamily="34" charset="-122"/>
                 <a:cs typeface="Consolas" pitchFamily="34" charset="-120"/>
               </a:rPr>
-              <a:t>MaxGPT  ·  Max — CS Final Project</a:t>
+              <a:t>MaxGPT  ·  Max, CS Final Project</a:t>
             </a:r>
             <a:endParaRPr lang="en-US" sz="900" dirty="0"/>
           </a:p>
@@ -13678,7 +13678,7 @@
                 <a:ea typeface="Trebuchet MS" pitchFamily="34" charset="-122"/>
                 <a:cs typeface="Trebuchet MS" pitchFamily="34" charset="-120"/>
               </a:rPr>
-              <a:t>Going further — fine-tuning + a real evaluation</a:t>
+              <a:t>Going further: fine-tuning + a real evaluation</a:t>
             </a:r>
             <a:endParaRPr lang="en-US" sz="2800" dirty="0"/>
           </a:p>
@@ -13916,7 +13916,7 @@
                 <a:ea typeface="Calibri" pitchFamily="34" charset="-122"/>
                 <a:cs typeface="Calibri" pitchFamily="34" charset="-120"/>
               </a:rPr>
-              <a:t> — so it only learns to reply, not to imitate the user. → MaxGPT-3.5</a:t>
+              <a:t>, so it only learns to reply, not to imitate the user. → MaxGPT-3.5</a:t>
             </a:r>
             <a:endParaRPr lang="en-US" sz="1400" dirty="0"/>
           </a:p>
@@ -14040,7 +14040,7 @@
                 <a:ea typeface="Calibri" pitchFamily="34" charset="-122"/>
                 <a:cs typeface="Calibri" pitchFamily="34" charset="-120"/>
               </a:rPr>
-              <a:t>Finding: SFT specialized the model — big wins in reference-resolution + assistant behavior, but more verbose. A measured trade-off, not a pure upgrade.</a:t>
+              <a:t>Finding: SFT specialized the model, big wins in reference-resolution + assistant behavior, but more verbose. A measured trade-off, not a pure upgrade.</a:t>
             </a:r>
             <a:endParaRPr lang="en-US" sz="1300" dirty="0"/>
           </a:p>
@@ -14150,7 +14150,7 @@
                 <a:ea typeface="Calibri" pitchFamily="34" charset="-122"/>
                 <a:cs typeface="Calibri" pitchFamily="34" charset="-120"/>
               </a:rPr>
-              <a:t>“I adopted a puppy named Rex … what should I feed HIM?”  —  % that correctly used the earlier turn</a:t>
+              <a:t>“I adopted a puppy named Rex … what should I feed HIM?”  ·  % that correctly used the earlier turn</a:t>
             </a:r>
             <a:endParaRPr lang="en-US" sz="1200" dirty="0"/>
           </a:p>
@@ -14205,7 +14205,7 @@
                 <a:ea typeface="Consolas" pitchFamily="34" charset="-122"/>
                 <a:cs typeface="Consolas" pitchFamily="34" charset="-120"/>
               </a:rPr>
-              <a:t>MaxGPT  ·  Max — CS Final Project</a:t>
+              <a:t>MaxGPT  ·  Max, CS Final Project</a:t>
             </a:r>
             <a:endParaRPr lang="en-US" sz="900" dirty="0"/>
           </a:p>

</xml_diff>